<commit_message>
Added order history page
</commit_message>
<xml_diff>
--- a/Webshop_Berchtold/Endpräsentation_Webshop.pptx
+++ b/Webshop_Berchtold/Endpräsentation_Webshop.pptx
@@ -152,6 +152,43 @@
     </p:ext>
   </p:extLst>
 </p:presentation>
+</file>
+
+<file path=ppt/revisionInfo.xml><?xml version="1.0" encoding="utf-8"?>
+<p1510:revInfo xmlns:a="http://schemas.openxmlformats.org/drawingml/2006/main" xmlns:r="http://schemas.openxmlformats.org/officeDocument/2006/relationships" xmlns:p1510="http://schemas.microsoft.com/office/powerpoint/2015/10/main">
+  <p1510:revLst>
+    <p1510:client id="{B36E7DE1-3E05-4924-AE1E-02D805B14A3A}" v="1" dt="2026-01-21T06:45:08.694"/>
+  </p1510:revLst>
+</p1510:revInfo>
+</file>
+
+<file path=ppt/changesInfos/changesInfo1.xml><?xml version="1.0" encoding="utf-8"?>
+<pc:chgInfo xmlns:a="http://schemas.openxmlformats.org/drawingml/2006/main" xmlns:r="http://schemas.openxmlformats.org/officeDocument/2006/relationships" xmlns:ac="http://schemas.microsoft.com/office/drawing/2013/main/command" xmlns:pc="http://schemas.microsoft.com/office/powerpoint/2013/main/command">
+  <pc:docChgLst>
+    <pc:chgData name="Laurenz Berchtold" userId="bf8fbad8-d71e-4779-ab0c-ba75c9f855a2" providerId="ADAL" clId="{6AB3C900-B65B-4149-B75B-040B4FBC2CE3}"/>
+    <pc:docChg chg="modSld">
+      <pc:chgData name="Laurenz Berchtold" userId="bf8fbad8-d71e-4779-ab0c-ba75c9f855a2" providerId="ADAL" clId="{6AB3C900-B65B-4149-B75B-040B4FBC2CE3}" dt="2026-01-21T06:33:56.340" v="1" actId="20577"/>
+      <pc:docMkLst>
+        <pc:docMk/>
+      </pc:docMkLst>
+      <pc:sldChg chg="modSp mod">
+        <pc:chgData name="Laurenz Berchtold" userId="bf8fbad8-d71e-4779-ab0c-ba75c9f855a2" providerId="ADAL" clId="{6AB3C900-B65B-4149-B75B-040B4FBC2CE3}" dt="2026-01-21T06:33:56.340" v="1" actId="20577"/>
+        <pc:sldMkLst>
+          <pc:docMk/>
+          <pc:sldMk cId="1017764230" sldId="276"/>
+        </pc:sldMkLst>
+        <pc:spChg chg="mod">
+          <ac:chgData name="Laurenz Berchtold" userId="bf8fbad8-d71e-4779-ab0c-ba75c9f855a2" providerId="ADAL" clId="{6AB3C900-B65B-4149-B75B-040B4FBC2CE3}" dt="2026-01-21T06:33:56.340" v="1" actId="20577"/>
+          <ac:spMkLst>
+            <pc:docMk/>
+            <pc:sldMk cId="1017764230" sldId="276"/>
+            <ac:spMk id="3" creationId="{0CDD7A6D-2E3D-758C-D528-FBC7B37B8387}"/>
+          </ac:spMkLst>
+        </pc:spChg>
+      </pc:sldChg>
+    </pc:docChg>
+  </pc:docChgLst>
+</pc:chgInfo>
 </file>
 
 <file path=ppt/diagrams/colors1.xml><?xml version="1.0" encoding="utf-8"?>
@@ -2434,7 +2471,26 @@
     </dgm:pt>
     <dgm:pt modelId="{DC31E1D1-9C91-468F-BC73-80A3827B437C}" type="pres">
       <dgm:prSet presAssocID="{0E29D4EF-A949-46DC-B9D6-EDE3F482AD21}" presName="iconRect" presStyleLbl="node1" presStyleIdx="2" presStyleCnt="3"/>
-      <dgm:spPr/>
+      <dgm:spPr>
+        <a:blipFill>
+          <a:blip xmlns:r="http://schemas.openxmlformats.org/officeDocument/2006/relationships" r:embed="rId5">
+            <a:extLst>
+              <a:ext uri="{96DAC541-7B7A-43D3-8B79-37D633B846F1}">
+                <asvg:svgBlip xmlns:asvg="http://schemas.microsoft.com/office/drawing/2016/SVG/main" r:embed="rId6"/>
+              </a:ext>
+            </a:extLst>
+          </a:blip>
+          <a:srcRect/>
+          <a:stretch>
+            <a:fillRect/>
+          </a:stretch>
+        </a:blipFill>
+      </dgm:spPr>
+      <dgm:extLst>
+        <a:ext uri="{E40237B7-FDA0-4F09-8148-C483321AD2D9}">
+          <dgm14:cNvPr xmlns:dgm14="http://schemas.microsoft.com/office/drawing/2010/diagram" id="0" name="" descr="Pfeil nach rechts mit einfarbiger Füllung"/>
+        </a:ext>
+      </dgm:extLst>
     </dgm:pt>
     <dgm:pt modelId="{1112D44E-F522-45D4-8729-641EA935C370}" type="pres">
       <dgm:prSet presAssocID="{0E29D4EF-A949-46DC-B9D6-EDE3F482AD21}" presName="spaceRect" presStyleCnt="0"/>
@@ -3677,14 +3733,19 @@
         <a:prstGeom prst="rect">
           <a:avLst/>
         </a:prstGeom>
-        <a:solidFill>
-          <a:schemeClr val="accent1">
-            <a:hueOff val="0"/>
-            <a:satOff val="0"/>
-            <a:lumOff val="0"/>
-            <a:alphaOff val="0"/>
-          </a:schemeClr>
-        </a:solidFill>
+        <a:blipFill>
+          <a:blip xmlns:r="http://schemas.openxmlformats.org/officeDocument/2006/relationships" r:embed="rId5">
+            <a:extLst>
+              <a:ext uri="{96DAC541-7B7A-43D3-8B79-37D633B846F1}">
+                <asvg:svgBlip xmlns:asvg="http://schemas.microsoft.com/office/drawing/2016/SVG/main" r:embed="rId6"/>
+              </a:ext>
+            </a:extLst>
+          </a:blip>
+          <a:srcRect/>
+          <a:stretch>
+            <a:fillRect/>
+          </a:stretch>
+        </a:blipFill>
         <a:ln w="19050" cap="flat" cmpd="sng" algn="ctr">
           <a:solidFill>
             <a:schemeClr val="lt1">
@@ -6516,7 +6577,7 @@
           <a:p>
             <a:fld id="{A87E9BDD-2EC8-4FC5-8506-23DBD186366C}" type="datetimeFigureOut">
               <a:rPr lang="de-AT" smtClean="0"/>
-              <a:t>19.01.2026</a:t>
+              <a:t>21.01.2026</a:t>
             </a:fld>
             <a:endParaRPr lang="de-AT"/>
           </a:p>
@@ -6933,7 +6994,7 @@
           <a:p>
             <a:fld id="{A283F6F3-EBD4-4A96-B1FC-B82E01871E33}" type="datetimeFigureOut">
               <a:rPr lang="de-AT" smtClean="0"/>
-              <a:t>19.01.2026</a:t>
+              <a:t>21.01.2026</a:t>
             </a:fld>
             <a:endParaRPr lang="de-AT"/>
           </a:p>
@@ -7133,7 +7194,7 @@
           <a:p>
             <a:fld id="{A283F6F3-EBD4-4A96-B1FC-B82E01871E33}" type="datetimeFigureOut">
               <a:rPr lang="de-AT" smtClean="0"/>
-              <a:t>19.01.2026</a:t>
+              <a:t>21.01.2026</a:t>
             </a:fld>
             <a:endParaRPr lang="de-AT"/>
           </a:p>
@@ -7343,7 +7404,7 @@
           <a:p>
             <a:fld id="{A283F6F3-EBD4-4A96-B1FC-B82E01871E33}" type="datetimeFigureOut">
               <a:rPr lang="de-AT" smtClean="0"/>
-              <a:t>19.01.2026</a:t>
+              <a:t>21.01.2026</a:t>
             </a:fld>
             <a:endParaRPr lang="de-AT"/>
           </a:p>
@@ -7543,7 +7604,7 @@
           <a:p>
             <a:fld id="{A283F6F3-EBD4-4A96-B1FC-B82E01871E33}" type="datetimeFigureOut">
               <a:rPr lang="de-AT" smtClean="0"/>
-              <a:t>19.01.2026</a:t>
+              <a:t>21.01.2026</a:t>
             </a:fld>
             <a:endParaRPr lang="de-AT"/>
           </a:p>
@@ -7819,7 +7880,7 @@
           <a:p>
             <a:fld id="{A283F6F3-EBD4-4A96-B1FC-B82E01871E33}" type="datetimeFigureOut">
               <a:rPr lang="de-AT" smtClean="0"/>
-              <a:t>19.01.2026</a:t>
+              <a:t>21.01.2026</a:t>
             </a:fld>
             <a:endParaRPr lang="de-AT"/>
           </a:p>
@@ -8087,7 +8148,7 @@
           <a:p>
             <a:fld id="{A283F6F3-EBD4-4A96-B1FC-B82E01871E33}" type="datetimeFigureOut">
               <a:rPr lang="de-AT" smtClean="0"/>
-              <a:t>19.01.2026</a:t>
+              <a:t>21.01.2026</a:t>
             </a:fld>
             <a:endParaRPr lang="de-AT"/>
           </a:p>
@@ -8502,7 +8563,7 @@
           <a:p>
             <a:fld id="{A283F6F3-EBD4-4A96-B1FC-B82E01871E33}" type="datetimeFigureOut">
               <a:rPr lang="de-AT" smtClean="0"/>
-              <a:t>19.01.2026</a:t>
+              <a:t>21.01.2026</a:t>
             </a:fld>
             <a:endParaRPr lang="de-AT"/>
           </a:p>
@@ -8644,7 +8705,7 @@
           <a:p>
             <a:fld id="{A283F6F3-EBD4-4A96-B1FC-B82E01871E33}" type="datetimeFigureOut">
               <a:rPr lang="de-AT" smtClean="0"/>
-              <a:t>19.01.2026</a:t>
+              <a:t>21.01.2026</a:t>
             </a:fld>
             <a:endParaRPr lang="de-AT"/>
           </a:p>
@@ -8757,7 +8818,7 @@
           <a:p>
             <a:fld id="{A283F6F3-EBD4-4A96-B1FC-B82E01871E33}" type="datetimeFigureOut">
               <a:rPr lang="de-AT" smtClean="0"/>
-              <a:t>19.01.2026</a:t>
+              <a:t>21.01.2026</a:t>
             </a:fld>
             <a:endParaRPr lang="de-AT"/>
           </a:p>
@@ -9070,7 +9131,7 @@
           <a:p>
             <a:fld id="{A283F6F3-EBD4-4A96-B1FC-B82E01871E33}" type="datetimeFigureOut">
               <a:rPr lang="de-AT" smtClean="0"/>
-              <a:t>19.01.2026</a:t>
+              <a:t>21.01.2026</a:t>
             </a:fld>
             <a:endParaRPr lang="de-AT"/>
           </a:p>
@@ -9359,7 +9420,7 @@
           <a:p>
             <a:fld id="{A283F6F3-EBD4-4A96-B1FC-B82E01871E33}" type="datetimeFigureOut">
               <a:rPr lang="de-AT" smtClean="0"/>
-              <a:t>19.01.2026</a:t>
+              <a:t>21.01.2026</a:t>
             </a:fld>
             <a:endParaRPr lang="de-AT"/>
           </a:p>
@@ -9602,7 +9663,7 @@
           <a:p>
             <a:fld id="{A283F6F3-EBD4-4A96-B1FC-B82E01871E33}" type="datetimeFigureOut">
               <a:rPr lang="de-AT" smtClean="0"/>
-              <a:t>19.01.2026</a:t>
+              <a:t>21.01.2026</a:t>
             </a:fld>
             <a:endParaRPr lang="de-AT"/>
           </a:p>
@@ -13476,10 +13537,6 @@
               <a:rPr lang="de-DE" sz="2800" b="1" dirty="0" err="1"/>
               <a:t>Checkout</a:t>
             </a:r>
-            <a:r>
-              <a:rPr lang="de-DE" sz="2800" b="1" dirty="0"/>
-              <a:t> nicht vollständig umgesetzt</a:t>
-            </a:r>
             <a:endParaRPr lang="de-DE" b="1" dirty="0"/>
           </a:p>
           <a:p>

</xml_diff>